<commit_message>
added lecture 7 notes on O-notation
</commit_message>
<xml_diff>
--- a/lectures/lecture5_6/lecture6.pptx
+++ b/lectures/lecture5_6/lecture6.pptx
@@ -130,81 +130,16 @@
   <pc:docChgLst>
     <pc:chgData name="Toby Donaldson" userId="2e6e5431-bb17-4c41-9985-d39c50d83c73" providerId="ADAL" clId="{F31BC264-820E-54C4-A6D1-F92AF9CC222E}"/>
     <pc:docChg chg="undo custSel addSld delSld modSld">
-      <pc:chgData name="Toby Donaldson" userId="2e6e5431-bb17-4c41-9985-d39c50d83c73" providerId="ADAL" clId="{F31BC264-820E-54C4-A6D1-F92AF9CC222E}" dt="2026-05-19T17:51:35.320" v="170" actId="2696"/>
+      <pc:chgData name="Toby Donaldson" userId="2e6e5431-bb17-4c41-9985-d39c50d83c73" providerId="ADAL" clId="{F31BC264-820E-54C4-A6D1-F92AF9CC222E}" dt="2026-05-21T21:02:20.201" v="192" actId="20577"/>
       <pc:docMkLst>
         <pc:docMk/>
       </pc:docMkLst>
-      <pc:sldChg chg="del">
-        <pc:chgData name="Toby Donaldson" userId="2e6e5431-bb17-4c41-9985-d39c50d83c73" providerId="ADAL" clId="{F31BC264-820E-54C4-A6D1-F92AF9CC222E}" dt="2026-05-19T17:51:35.320" v="170" actId="2696"/>
-        <pc:sldMkLst>
-          <pc:docMk/>
-          <pc:sldMk cId="917661366" sldId="256"/>
-        </pc:sldMkLst>
-      </pc:sldChg>
-      <pc:sldChg chg="del">
-        <pc:chgData name="Toby Donaldson" userId="2e6e5431-bb17-4c41-9985-d39c50d83c73" providerId="ADAL" clId="{F31BC264-820E-54C4-A6D1-F92AF9CC222E}" dt="2026-05-19T17:44:06.340" v="0" actId="2696"/>
-        <pc:sldMkLst>
-          <pc:docMk/>
-          <pc:sldMk cId="3882066604" sldId="257"/>
-        </pc:sldMkLst>
-      </pc:sldChg>
-      <pc:sldChg chg="del">
-        <pc:chgData name="Toby Donaldson" userId="2e6e5431-bb17-4c41-9985-d39c50d83c73" providerId="ADAL" clId="{F31BC264-820E-54C4-A6D1-F92AF9CC222E}" dt="2026-05-19T17:44:06.340" v="0" actId="2696"/>
-        <pc:sldMkLst>
-          <pc:docMk/>
-          <pc:sldMk cId="2285235809" sldId="258"/>
-        </pc:sldMkLst>
-      </pc:sldChg>
-      <pc:sldChg chg="del">
-        <pc:chgData name="Toby Donaldson" userId="2e6e5431-bb17-4c41-9985-d39c50d83c73" providerId="ADAL" clId="{F31BC264-820E-54C4-A6D1-F92AF9CC222E}" dt="2026-05-19T17:44:06.340" v="0" actId="2696"/>
-        <pc:sldMkLst>
-          <pc:docMk/>
-          <pc:sldMk cId="2983885050" sldId="259"/>
-        </pc:sldMkLst>
-      </pc:sldChg>
-      <pc:sldChg chg="del">
-        <pc:chgData name="Toby Donaldson" userId="2e6e5431-bb17-4c41-9985-d39c50d83c73" providerId="ADAL" clId="{F31BC264-820E-54C4-A6D1-F92AF9CC222E}" dt="2026-05-19T17:44:06.340" v="0" actId="2696"/>
-        <pc:sldMkLst>
-          <pc:docMk/>
-          <pc:sldMk cId="3378692664" sldId="260"/>
-        </pc:sldMkLst>
-      </pc:sldChg>
-      <pc:sldChg chg="del">
-        <pc:chgData name="Toby Donaldson" userId="2e6e5431-bb17-4c41-9985-d39c50d83c73" providerId="ADAL" clId="{F31BC264-820E-54C4-A6D1-F92AF9CC222E}" dt="2026-05-19T17:51:31.895" v="169" actId="2696"/>
-        <pc:sldMkLst>
-          <pc:docMk/>
-          <pc:sldMk cId="3079706127" sldId="261"/>
-        </pc:sldMkLst>
-      </pc:sldChg>
-      <pc:sldChg chg="del">
-        <pc:chgData name="Toby Donaldson" userId="2e6e5431-bb17-4c41-9985-d39c50d83c73" providerId="ADAL" clId="{F31BC264-820E-54C4-A6D1-F92AF9CC222E}" dt="2026-05-19T17:44:14.023" v="1" actId="2696"/>
-        <pc:sldMkLst>
-          <pc:docMk/>
-          <pc:sldMk cId="570944480" sldId="262"/>
-        </pc:sldMkLst>
-      </pc:sldChg>
       <pc:sldChg chg="addSp delSp modSp new mod">
         <pc:chgData name="Toby Donaldson" userId="2e6e5431-bb17-4c41-9985-d39c50d83c73" providerId="ADAL" clId="{F31BC264-820E-54C4-A6D1-F92AF9CC222E}" dt="2026-05-19T17:51:18.248" v="168" actId="20577"/>
         <pc:sldMkLst>
           <pc:docMk/>
           <pc:sldMk cId="2832120286" sldId="262"/>
         </pc:sldMkLst>
-        <pc:spChg chg="mod">
-          <ac:chgData name="Toby Donaldson" userId="2e6e5431-bb17-4c41-9985-d39c50d83c73" providerId="ADAL" clId="{F31BC264-820E-54C4-A6D1-F92AF9CC222E}" dt="2026-05-19T17:44:44.085" v="52" actId="20577"/>
-          <ac:spMkLst>
-            <pc:docMk/>
-            <pc:sldMk cId="2832120286" sldId="262"/>
-            <ac:spMk id="2" creationId="{35326877-1393-A1DC-DE4F-70F8C375811D}"/>
-          </ac:spMkLst>
-        </pc:spChg>
-        <pc:spChg chg="del">
-          <ac:chgData name="Toby Donaldson" userId="2e6e5431-bb17-4c41-9985-d39c50d83c73" providerId="ADAL" clId="{F31BC264-820E-54C4-A6D1-F92AF9CC222E}" dt="2026-05-19T17:44:48.166" v="53" actId="21"/>
-          <ac:spMkLst>
-            <pc:docMk/>
-            <pc:sldMk cId="2832120286" sldId="262"/>
-            <ac:spMk id="3" creationId="{D91F4E37-040E-92D3-EC72-8A9F222A120F}"/>
-          </ac:spMkLst>
-        </pc:spChg>
         <pc:spChg chg="add mod">
           <ac:chgData name="Toby Donaldson" userId="2e6e5431-bb17-4c41-9985-d39c50d83c73" providerId="ADAL" clId="{F31BC264-820E-54C4-A6D1-F92AF9CC222E}" dt="2026-05-19T17:45:14.132" v="55" actId="207"/>
           <ac:spMkLst>
@@ -358,12 +293,35 @@
           </ac:cxnSpMkLst>
         </pc:cxnChg>
       </pc:sldChg>
-      <pc:sldChg chg="del">
-        <pc:chgData name="Toby Donaldson" userId="2e6e5431-bb17-4c41-9985-d39c50d83c73" providerId="ADAL" clId="{F31BC264-820E-54C4-A6D1-F92AF9CC222E}" dt="2026-05-19T17:44:14.023" v="1" actId="2696"/>
+      <pc:sldChg chg="modSp mod">
+        <pc:chgData name="Toby Donaldson" userId="2e6e5431-bb17-4c41-9985-d39c50d83c73" providerId="ADAL" clId="{F31BC264-820E-54C4-A6D1-F92AF9CC222E}" dt="2026-05-21T20:59:39.979" v="184" actId="20577"/>
         <pc:sldMkLst>
           <pc:docMk/>
-          <pc:sldMk cId="1725074489" sldId="263"/>
+          <pc:sldMk cId="3605549294" sldId="265"/>
         </pc:sldMkLst>
+        <pc:spChg chg="mod">
+          <ac:chgData name="Toby Donaldson" userId="2e6e5431-bb17-4c41-9985-d39c50d83c73" providerId="ADAL" clId="{F31BC264-820E-54C4-A6D1-F92AF9CC222E}" dt="2026-05-21T20:59:39.979" v="184" actId="20577"/>
+          <ac:spMkLst>
+            <pc:docMk/>
+            <pc:sldMk cId="3605549294" sldId="265"/>
+            <ac:spMk id="14" creationId="{078CC05A-F085-CCF1-7995-F4B68298AEDA}"/>
+          </ac:spMkLst>
+        </pc:spChg>
+      </pc:sldChg>
+      <pc:sldChg chg="modSp mod">
+        <pc:chgData name="Toby Donaldson" userId="2e6e5431-bb17-4c41-9985-d39c50d83c73" providerId="ADAL" clId="{F31BC264-820E-54C4-A6D1-F92AF9CC222E}" dt="2026-05-21T21:02:20.201" v="192" actId="20577"/>
+        <pc:sldMkLst>
+          <pc:docMk/>
+          <pc:sldMk cId="4050151651" sldId="267"/>
+        </pc:sldMkLst>
+        <pc:spChg chg="mod">
+          <ac:chgData name="Toby Donaldson" userId="2e6e5431-bb17-4c41-9985-d39c50d83c73" providerId="ADAL" clId="{F31BC264-820E-54C4-A6D1-F92AF9CC222E}" dt="2026-05-21T21:02:20.201" v="192" actId="20577"/>
+          <ac:spMkLst>
+            <pc:docMk/>
+            <pc:sldMk cId="4050151651" sldId="267"/>
+            <ac:spMk id="14" creationId="{35BF56E4-5D20-18D9-8C84-B81AFD063048}"/>
+          </ac:spMkLst>
+        </pc:spChg>
       </pc:sldChg>
     </pc:docChg>
   </pc:docChgLst>
@@ -1024,7 +982,7 @@
           <a:p>
             <a:fld id="{889F9635-12D6-CA48-83F0-27F24E8721A6}" type="datetimeFigureOut">
               <a:rPr lang="en-US" smtClean="0"/>
-              <a:t>5/20/26</a:t>
+              <a:t>5/21/26</a:t>
             </a:fld>
             <a:endParaRPr lang="en-US"/>
           </a:p>
@@ -1222,7 +1180,7 @@
           <a:p>
             <a:fld id="{889F9635-12D6-CA48-83F0-27F24E8721A6}" type="datetimeFigureOut">
               <a:rPr lang="en-US" smtClean="0"/>
-              <a:t>5/20/26</a:t>
+              <a:t>5/21/26</a:t>
             </a:fld>
             <a:endParaRPr lang="en-US"/>
           </a:p>
@@ -1430,7 +1388,7 @@
           <a:p>
             <a:fld id="{889F9635-12D6-CA48-83F0-27F24E8721A6}" type="datetimeFigureOut">
               <a:rPr lang="en-US" smtClean="0"/>
-              <a:t>5/20/26</a:t>
+              <a:t>5/21/26</a:t>
             </a:fld>
             <a:endParaRPr lang="en-US"/>
           </a:p>
@@ -1628,7 +1586,7 @@
           <a:p>
             <a:fld id="{889F9635-12D6-CA48-83F0-27F24E8721A6}" type="datetimeFigureOut">
               <a:rPr lang="en-US" smtClean="0"/>
-              <a:t>5/20/26</a:t>
+              <a:t>5/21/26</a:t>
             </a:fld>
             <a:endParaRPr lang="en-US"/>
           </a:p>
@@ -1903,7 +1861,7 @@
           <a:p>
             <a:fld id="{889F9635-12D6-CA48-83F0-27F24E8721A6}" type="datetimeFigureOut">
               <a:rPr lang="en-US" smtClean="0"/>
-              <a:t>5/20/26</a:t>
+              <a:t>5/21/26</a:t>
             </a:fld>
             <a:endParaRPr lang="en-US"/>
           </a:p>
@@ -2168,7 +2126,7 @@
           <a:p>
             <a:fld id="{889F9635-12D6-CA48-83F0-27F24E8721A6}" type="datetimeFigureOut">
               <a:rPr lang="en-US" smtClean="0"/>
-              <a:t>5/20/26</a:t>
+              <a:t>5/21/26</a:t>
             </a:fld>
             <a:endParaRPr lang="en-US"/>
           </a:p>
@@ -2580,7 +2538,7 @@
           <a:p>
             <a:fld id="{889F9635-12D6-CA48-83F0-27F24E8721A6}" type="datetimeFigureOut">
               <a:rPr lang="en-US" smtClean="0"/>
-              <a:t>5/20/26</a:t>
+              <a:t>5/21/26</a:t>
             </a:fld>
             <a:endParaRPr lang="en-US"/>
           </a:p>
@@ -2721,7 +2679,7 @@
           <a:p>
             <a:fld id="{889F9635-12D6-CA48-83F0-27F24E8721A6}" type="datetimeFigureOut">
               <a:rPr lang="en-US" smtClean="0"/>
-              <a:t>5/20/26</a:t>
+              <a:t>5/21/26</a:t>
             </a:fld>
             <a:endParaRPr lang="en-US"/>
           </a:p>
@@ -2834,7 +2792,7 @@
           <a:p>
             <a:fld id="{889F9635-12D6-CA48-83F0-27F24E8721A6}" type="datetimeFigureOut">
               <a:rPr lang="en-US" smtClean="0"/>
-              <a:t>5/20/26</a:t>
+              <a:t>5/21/26</a:t>
             </a:fld>
             <a:endParaRPr lang="en-US"/>
           </a:p>
@@ -3145,7 +3103,7 @@
           <a:p>
             <a:fld id="{889F9635-12D6-CA48-83F0-27F24E8721A6}" type="datetimeFigureOut">
               <a:rPr lang="en-US" smtClean="0"/>
-              <a:t>5/20/26</a:t>
+              <a:t>5/21/26</a:t>
             </a:fld>
             <a:endParaRPr lang="en-US"/>
           </a:p>
@@ -3433,7 +3391,7 @@
           <a:p>
             <a:fld id="{889F9635-12D6-CA48-83F0-27F24E8721A6}" type="datetimeFigureOut">
               <a:rPr lang="en-US" smtClean="0"/>
-              <a:t>5/20/26</a:t>
+              <a:t>5/21/26</a:t>
             </a:fld>
             <a:endParaRPr lang="en-US"/>
           </a:p>
@@ -3674,7 +3632,7 @@
           <a:p>
             <a:fld id="{889F9635-12D6-CA48-83F0-27F24E8721A6}" type="datetimeFigureOut">
               <a:rPr lang="en-US" smtClean="0"/>
-              <a:t>5/20/26</a:t>
+              <a:t>5/21/26</a:t>
             </a:fld>
             <a:endParaRPr lang="en-US"/>
           </a:p>
@@ -7560,7 +7518,7 @@
           <a:p>
             <a:r>
               <a:rPr lang="en-US" dirty="0"/>
-              <a:t>Singly-linked list: head and tail pointer</a:t>
+              <a:t>Doubly-linked list: head and tail pointer</a:t>
             </a:r>
           </a:p>
         </p:txBody>
@@ -9022,8 +8980,12 @@
           <a:lstStyle/>
           <a:p>
             <a:r>
+              <a:rPr lang="en-US"/>
+              <a:t>Doubly-linked </a:t>
+            </a:r>
+            <a:r>
               <a:rPr lang="en-US" dirty="0"/>
-              <a:t>Singly-linked list: head and tail pointer</a:t>
+              <a:t>list: head and tail pointer</a:t>
             </a:r>
           </a:p>
         </p:txBody>

</xml_diff>